<commit_message>
Takım en çok 5 kişi, 10 dakikalık gösterim yerleri, depo şablondan (fork yok), paylaşılan takım listesi; çıktılar yeniden üretildi
</commit_message>
<xml_diff>
--- a/docs/prerequisites/cen429-on-gereksinimler-sunum.en.pptx
+++ b/docs/prerequisites/cen429-on-gereksinimler-sunum.en.pptx
@@ -7296,7 +7296,7 @@
         <p:spPr>
           <a:xfrm>
             <a:off x="640080" y="1325880"/>
-            <a:ext cx="10911535" cy="439928"/>
+            <a:ext cx="10911535" cy="770128"/>
           </a:xfrm>
           <a:prstGeom prst="rect">
             <a:avLst/>
@@ -7316,7 +7316,7 @@
                   <a:srgbClr val="1F2D3A"/>
                 </a:solidFill>
               </a:rPr>
-              <a:t>Fork the project template to your own account, build it and run its tests:</a:t>
+              <a:t>Create your own private repository from the project template ("Use this template → Private", not fork), build it and run its tests:</a:t>
             </a:r>
           </a:p>
         </p:txBody>
@@ -7329,7 +7329,7 @@
         </p:nvSpPr>
         <p:spPr>
           <a:xfrm>
-            <a:off x="640080" y="1875536"/>
+            <a:off x="640080" y="2205736"/>
             <a:ext cx="10911535" cy="1219200"/>
           </a:xfrm>
           <a:prstGeom prst="rect">
@@ -7930,7 +7930,7 @@
         </p:nvGraphicFramePr>
         <p:xfrm>
           <a:off x="640080" y="1325880"/>
-          <a:ext cx="10911534" cy="2459735"/>
+          <a:ext cx="10911534" cy="2697479"/>
         </p:xfrm>
         <a:graphic>
           <a:graphicData uri="http://schemas.openxmlformats.org/drawingml/2006/table">
@@ -7939,10 +7939,10 @@
                 <a:tableStyleId>{5C22544A-7EE6-4342-B048-85BDC9FD1C3A}</a:tableStyleId>
               </a:tblPr>
               <a:tblGrid>
-                <a:gridCol w="1769438"/>
-                <a:gridCol w="9142096"/>
+                <a:gridCol w="2102222"/>
+                <a:gridCol w="8809312"/>
               </a:tblGrid>
-              <a:tr h="409955">
+              <a:tr h="449579">
                 <a:tc>
                   <a:txBody>
                     <a:bodyPr wrap="square"/>
@@ -7986,7 +7986,7 @@
                   </a:tcPr>
                 </a:tc>
               </a:tr>
-              <a:tr h="409955">
+              <a:tr h="449579">
                 <a:tc>
                   <a:txBody>
                     <a:bodyPr wrap="square"/>
@@ -8030,7 +8030,7 @@
                   </a:tcPr>
                 </a:tc>
               </a:tr>
-              <a:tr h="409955">
+              <a:tr h="449579">
                 <a:tc>
                   <a:txBody>
                     <a:bodyPr wrap="square"/>
@@ -8074,7 +8074,7 @@
                   </a:tcPr>
                 </a:tc>
               </a:tr>
-              <a:tr h="409955">
+              <a:tr h="449579">
                 <a:tc>
                   <a:txBody>
                     <a:bodyPr wrap="square"/>
@@ -8118,7 +8118,7 @@
                   </a:tcPr>
                 </a:tc>
               </a:tr>
-              <a:tr h="409955">
+              <a:tr h="449579">
                 <a:tc>
                   <a:txBody>
                     <a:bodyPr wrap="square"/>
@@ -8130,7 +8130,7 @@
                             <a:srgbClr val="1F2D3A"/>
                           </a:solidFill>
                         </a:rPr>
-                        <a:t>Fork</a:t>
+                        <a:t>Use this template</a:t>
                       </a:r>
                     </a:p>
                   </a:txBody>
@@ -8151,7 +8151,7 @@
                             <a:srgbClr val="1F2D3A"/>
                           </a:solidFill>
                         </a:rPr>
-                        <a:t>Making your own copy of a repository</a:t>
+                        <a:t>Opening a new repository with the template's files and no history; it can be private</a:t>
                       </a:r>
                     </a:p>
                   </a:txBody>
@@ -8162,7 +8162,7 @@
                   </a:tcPr>
                 </a:tc>
               </a:tr>
-              <a:tr h="409960">
+              <a:tr h="449584">
                 <a:tc>
                   <a:txBody>
                     <a:bodyPr wrap="square"/>
@@ -10707,7 +10707,7 @@
                   <a:srgbClr val="1F2D3A"/>
                 </a:solidFill>
               </a:rPr>
-              <a:t>Forking a template</a:t>
+              <a:t>Creating a private repository from a template ("Use this template", not fork)</a:t>
             </a:r>
           </a:p>
           <a:p>

</xml_diff>